<commit_message>
docs(presentation): scope Web Push to the iPhone/iPad Safari Home Screen PWA
The deployed Web Push channel serves only iPhone/iPad visitors who add the
Safari portal to their Home Screen, delivered via Apple's push service.
The architecture and notification slides, the free-tier table and the
architecture/capacity notes no longer present Google/Mozilla browser push
services as part of the product. Android push stays separate under FCM.

Co-Authored-By: Claude Opus 5.5 <noreply@anthropic.com>
Claude-Session: https://claude.ai/code/session_012AXSZrFXc46dERhV4B9Z4S
</commit_message>
<xml_diff>
--- a/docs/presentation/LiveQueue_Production_Presentation.pptx
+++ b/docs/presentation/LiveQueue_Production_Presentation.pptx
@@ -134,7 +134,7 @@
   <p:extLst>
     <p:ext uri="{521415D9-36F7-43E2-AB2F-B90AF26B5E84}">
       <p14:sectionLst xmlns:p14="http://schemas.microsoft.com/office/powerpoint/2010/main">
-        <p14:section name="Introduction" id="{deebc9f4-8fb8-0244-fac5-cd5eb0542f21}">
+        <p14:section name="Introduction" id="{0d4b9140-a621-11e9-bb6f-3550a938f85f}">
           <p14:sldIdLst>
             <p14:sldId id="256"/>
             <p14:sldId id="257"/>
@@ -142,45 +142,45 @@
             <p14:sldId id="259"/>
           </p14:sldIdLst>
         </p14:section>
-        <p14:section name="Architecture" id="{a6523f78-af93-3559-1e75-fb7e86b44503}">
+        <p14:section name="Architecture" id="{f991c95e-603a-6189-7601-27e6fbfeba49}">
           <p14:sldIdLst>
             <p14:sldId id="260"/>
             <p14:sldId id="261"/>
             <p14:sldId id="270"/>
           </p14:sldIdLst>
         </p14:section>
-        <p14:section name="Queue engine" id="{6d2fc166-9298-d31d-c05a-a9f359ca4627}">
+        <p14:section name="Queue engine" id="{4041f61c-b115-b7be-17e5-e89e7582ab15}">
           <p14:sldIdLst>
             <p14:sldId id="262"/>
             <p14:sldId id="263"/>
             <p14:sldId id="264"/>
           </p14:sldIdLst>
         </p14:section>
-        <p14:section name="Product" id="{a4c6ff61-8872-1224-1544-7fe31b892a20}">
+        <p14:section name="Product" id="{269d121d-499d-f751-827e-d14f224ecf05}">
           <p14:sldIdLst>
             <p14:sldId id="265"/>
             <p14:sldId id="266"/>
             <p14:sldId id="267"/>
           </p14:sldIdLst>
         </p14:section>
-        <p14:section name="Trust" id="{7af4ec6c-50a8-dcf4-7d18-2edd64b441fa}">
+        <p14:section name="Trust" id="{0038793d-356f-72c8-f656-521f7302ec38}">
           <p14:sldIdLst>
             <p14:sldId id="268"/>
             <p14:sldId id="269"/>
           </p14:sldIdLst>
         </p14:section>
-        <p14:section name="Delivery" id="{5010913a-80be-ce9c-13d1-eadf83e73426}">
+        <p14:section name="Delivery" id="{362030ea-9799-10ff-df18-c6430485f094}">
           <p14:sldIdLst>
             <p14:sldId id="271"/>
             <p14:sldId id="272"/>
           </p14:sldIdLst>
         </p14:section>
-        <p14:section name="Capacity, cost and scaling" id="{902027bf-beda-48e2-70d4-ceef9216b2fc}">
+        <p14:section name="Capacity, cost and scaling" id="{4465a14f-9486-431e-c511-73733513d2b3}">
           <p14:sldIdLst>
             <p14:sldId id="273"/>
           </p14:sldIdLst>
         </p14:section>
-        <p14:section name="Capacity" id="{fbac06f2-4f39-4de3-3209-ecc522db2bbf}">
+        <p14:section name="Capacity" id="{f2560def-f27d-6e8b-a96f-3788a91ec464}">
           <p14:sldIdLst>
             <p14:sldId id="274"/>
             <p14:sldId id="275"/>
@@ -189,19 +189,19 @@
             <p14:sldId id="278"/>
           </p14:sldIdLst>
         </p14:section>
-        <p14:section name="Scaling" id="{2a0ee2c8-3951-a121-c936-ad06f0fe1371}">
+        <p14:section name="Scaling" id="{bb42d52f-36a3-f446-15f2-876d734796c4}">
           <p14:sldIdLst>
             <p14:sldId id="279"/>
             <p14:sldId id="280"/>
             <p14:sldId id="281"/>
           </p14:sldIdLst>
         </p14:section>
-        <p14:section name="Demo" id="{d92ac995-e83b-222a-57c4-0e916b0ec23a}">
+        <p14:section name="Demo" id="{f2e048a9-1a79-3aa4-6bd7-f1a6ddff8f09}">
           <p14:sldIdLst>
             <p14:sldId id="282"/>
           </p14:sldIdLst>
         </p14:section>
-        <p14:section name="Conclusion" id="{a458b8ba-94c7-5293-cfa0-f0b252aa3092}">
+        <p14:section name="Conclusion" id="{a934222d-cbd5-2d8b-a8c5-03b89a6e713a}">
           <p14:sldIdLst>
             <p14:sldId id="283"/>
           </p14:sldIdLst>
@@ -2903,7 +2903,7 @@
           <a:p>
             <a:r>
               <a:rPr lang="en-US" dirty="0"/>
-              <a:t>Walk left to right. Three clients. One backend process on Render runs the REST API, the Socket.io server and two schedulers. PostgreSQL on Neon is the single source of truth via Prisma. Static dashboard and portal are served by Cloudflare Pages — note that API traffic goes straight to Render, not through Cloudflare. Notifications fan out to FCM, the browser push services and Resend for email. The console is a fourth surface in review.</a:t>
+              <a:t>Walk left to right. Three clients. One backend process on Render runs the REST API, the Socket.io server and two schedulers. PostgreSQL on Neon is the single source of truth via Prisma. Static dashboard and portal are served by Cloudflare Pages — note that API traffic goes straight to Render, not through Cloudflare. Notifications fan out to FCM for the Android app, Web Push for iPhone/iPad visitors who added the Safari portal to their Home Screen, and Resend for email. The console is a fourth surface in review.</a:t>
             </a:r>
             <a:endParaRPr lang="en-US" dirty="0"/>
           </a:p>
@@ -6003,7 +6003,7 @@
                   <a:srgbClr val="475569"/>
                 </a:solidFill>
               </a:rPr>
-              <a:t>iPhone / browser</a:t>
+              <a:t>iPhone/iPad Safari PWA</a:t>
             </a:r>
             <a:endParaRPr lang="en-US" sz="1200" dirty="0"/>
           </a:p>
@@ -6039,7 +6039,7 @@
                   <a:srgbClr val="475569"/>
                 </a:solidFill>
               </a:rPr>
-              <a:t>free · vendor push services</a:t>
+              <a:t>free · Apple push service</a:t>
             </a:r>
             <a:endParaRPr lang="en-US" sz="1050" dirty="0"/>
           </a:p>
@@ -12341,7 +12341,7 @@
                           <a:ea typeface="Calibri" pitchFamily="34" charset="-122"/>
                           <a:cs typeface="Calibri" pitchFamily="34" charset="-120"/>
                         </a:rPr>
-                        <a:t>Vendor push services; device rules apply</a:t>
+                        <a:t>iPhone/iPad Safari Home Screen PWA via Apple's push service; iOS/iPadOS 16.4+ and user permission</a:t>
                       </a:r>
                       <a:endParaRPr lang="en-US" sz="1150" dirty="0">
                         <a:latin typeface="Calibri" charset="0"/>
@@ -27088,12 +27088,12 @@
         </p:nvSpPr>
         <p:spPr>
           <a:xfrm>
-            <a:off x="6629400" y="1920240"/>
-            <a:ext cx="2103120" cy="566928"/>
+            <a:off x="6629400" y="1874520"/>
+            <a:ext cx="2103120" cy="658368"/>
           </a:xfrm>
           <a:prstGeom prst="roundRect">
             <a:avLst>
-              <a:gd name="adj" fmla="val 12903"/>
+              <a:gd name="adj" fmla="val 11111"/>
             </a:avLst>
           </a:prstGeom>
           <a:solidFill>
@@ -27115,8 +27115,8 @@
         </p:nvSpPr>
         <p:spPr>
           <a:xfrm>
-            <a:off x="6720840" y="1975104"/>
-            <a:ext cx="1920240" cy="457200"/>
+            <a:off x="6720840" y="1929384"/>
+            <a:ext cx="1920240" cy="548640"/>
           </a:xfrm>
           <a:prstGeom prst="rect">
             <a:avLst/>
@@ -27137,7 +27137,7 @@
                   <a:schemeClr val="tx1"/>
                 </a:solidFill>
               </a:rPr>
-              <a:t>Web Push services</a:t>
+              <a:t>Web Push</a:t>
             </a:r>
             <a:endParaRPr lang="en-US" sz="1200" dirty="0"/>
           </a:p>
@@ -27146,12 +27146,26 @@
               <a:buNone/>
             </a:pPr>
             <a:r>
-              <a:rPr lang="en-US" sz="1000" dirty="0">
+              <a:rPr lang="en-US" sz="950" dirty="0">
                 <a:solidFill>
                   <a:srgbClr val="475569"/>
                 </a:solidFill>
               </a:rPr>
-              <a:t>VAPID · Apple/Google/Mozilla</a:t>
+              <a:t>iPhone/iPad Safari (Home Screen PWA)</a:t>
+            </a:r>
+            <a:endParaRPr lang="en-US" sz="1200" dirty="0"/>
+          </a:p>
+          <a:p>
+            <a:pPr algn="ctr" indent="0" marL="0">
+              <a:buNone/>
+            </a:pPr>
+            <a:r>
+              <a:rPr lang="en-US" sz="950" dirty="0">
+                <a:solidFill>
+                  <a:srgbClr val="475569"/>
+                </a:solidFill>
+              </a:rPr>
+              <a:t>VAPID-based notifications</a:t>
             </a:r>
             <a:endParaRPr lang="en-US" sz="1200" dirty="0"/>
           </a:p>

</xml_diff>

<commit_message>
docs(presentation): reflect the 2026-10-09 production rollout
Master c17678b is live: the Floating Counter Console moves from "in
review" to production; the dashboard refetch storm, the iPhone/iPad portal
re-reads and the shared rate-limit bucket are shown as fixed (measured
before/after numbers); the first likely bottleneck is now Neon's free
quotas; capacity is ~300-500 waiting per queue, ~25,000 visits/month and
~5 small organizations, all marked ESTIMATE / NOT LOAD-TEST VALIDATED.
Web Push stays scoped to the iPhone/iPad Safari Home Screen PWA; Android
stays on FCM. Deck, PDF, capacity analysis, architecture summary and
faculty Q&A rebuilt together.

Co-Authored-By: Claude Opus 5.5 <noreply@anthropic.com>
Claude-Session: https://claude.ai/code/session_012AXSZrFXc46dERhV4B9Z4S
</commit_message>
<xml_diff>
--- a/docs/presentation/LiveQueue_Production_Presentation.pptx
+++ b/docs/presentation/LiveQueue_Production_Presentation.pptx
@@ -134,7 +134,7 @@
   <p:extLst>
     <p:ext uri="{521415D9-36F7-43E2-AB2F-B90AF26B5E84}">
       <p14:sectionLst xmlns:p14="http://schemas.microsoft.com/office/powerpoint/2010/main">
-        <p14:section name="Introduction" id="{0d4b9140-a621-11e9-bb6f-3550a938f85f}">
+        <p14:section name="Introduction" id="{14d8c2bc-3198-9f68-289f-6b63c3deef27}">
           <p14:sldIdLst>
             <p14:sldId id="256"/>
             <p14:sldId id="257"/>
@@ -142,45 +142,45 @@
             <p14:sldId id="259"/>
           </p14:sldIdLst>
         </p14:section>
-        <p14:section name="Architecture" id="{f991c95e-603a-6189-7601-27e6fbfeba49}">
+        <p14:section name="Architecture" id="{d15e1bf2-6905-9976-f4d8-90d7dcc67188}">
           <p14:sldIdLst>
             <p14:sldId id="260"/>
             <p14:sldId id="261"/>
             <p14:sldId id="270"/>
           </p14:sldIdLst>
         </p14:section>
-        <p14:section name="Queue engine" id="{4041f61c-b115-b7be-17e5-e89e7582ab15}">
+        <p14:section name="Queue engine" id="{f832b7ad-a739-f5b9-d9db-d793879fcc13}">
           <p14:sldIdLst>
             <p14:sldId id="262"/>
             <p14:sldId id="263"/>
             <p14:sldId id="264"/>
           </p14:sldIdLst>
         </p14:section>
-        <p14:section name="Product" id="{269d121d-499d-f751-827e-d14f224ecf05}">
+        <p14:section name="Product" id="{0494b43a-bcc9-b5ea-cca3-bafae06a8418}">
           <p14:sldIdLst>
             <p14:sldId id="265"/>
             <p14:sldId id="266"/>
             <p14:sldId id="267"/>
           </p14:sldIdLst>
         </p14:section>
-        <p14:section name="Trust" id="{0038793d-356f-72c8-f656-521f7302ec38}">
+        <p14:section name="Trust" id="{e3957cbe-b583-c2ce-990d-a40eab71f9cd}">
           <p14:sldIdLst>
             <p14:sldId id="268"/>
             <p14:sldId id="269"/>
           </p14:sldIdLst>
         </p14:section>
-        <p14:section name="Delivery" id="{362030ea-9799-10ff-df18-c6430485f094}">
+        <p14:section name="Delivery" id="{6c373a7c-2e38-2607-6e2e-d302581390f3}">
           <p14:sldIdLst>
             <p14:sldId id="271"/>
             <p14:sldId id="272"/>
           </p14:sldIdLst>
         </p14:section>
-        <p14:section name="Capacity, cost and scaling" id="{4465a14f-9486-431e-c511-73733513d2b3}">
+        <p14:section name="Capacity, cost and scaling" id="{e0a89dc2-51b6-3d79-f3ba-4f16b0ff872e}">
           <p14:sldIdLst>
             <p14:sldId id="273"/>
           </p14:sldIdLst>
         </p14:section>
-        <p14:section name="Capacity" id="{f2560def-f27d-6e8b-a96f-3788a91ec464}">
+        <p14:section name="Capacity" id="{98f543c0-5299-cf5f-a23d-3bf375cd7577}">
           <p14:sldIdLst>
             <p14:sldId id="274"/>
             <p14:sldId id="275"/>
@@ -189,19 +189,19 @@
             <p14:sldId id="278"/>
           </p14:sldIdLst>
         </p14:section>
-        <p14:section name="Scaling" id="{bb42d52f-36a3-f446-15f2-876d734796c4}">
+        <p14:section name="Scaling" id="{279e3158-b589-93f3-61df-e77ded5be4a0}">
           <p14:sldIdLst>
             <p14:sldId id="279"/>
             <p14:sldId id="280"/>
             <p14:sldId id="281"/>
           </p14:sldIdLst>
         </p14:section>
-        <p14:section name="Demo" id="{f2e048a9-1a79-3aa4-6bd7-f1a6ddff8f09}">
+        <p14:section name="Demo" id="{04698e45-6ab8-3672-69ba-24ac923c5a8b}">
           <p14:sldIdLst>
             <p14:sldId id="282"/>
           </p14:sldIdLst>
         </p14:section>
-        <p14:section name="Conclusion" id="{a934222d-cbd5-2d8b-a8c5-03b89a6e713a}">
+        <p14:section name="Conclusion" id="{f7ee7eb0-dcb9-acc9-e781-8ba0705fd3cd}">
           <p14:sldIdLst>
             <p14:sldId id="283"/>
           </p14:sldIdLst>
@@ -1319,7 +1319,7 @@
           <a:p>
             <a:r>
               <a:rPr lang="en-US" dirty="0"/>
-              <a:t>Left column: controls that exist in code and are covered by tests. Right column: honest limitations. The most important one to mention: rate limiting is in-memory and keyed on the client IP, and Express trust proxy is not configured, so behind Render's proxy many clients may share one limit. This was found while preparing this analysis and is not yet verified in production.</a:t>
+              <a:t>Left column: controls that exist in code and are covered by tests. Right column: honest limitations. Worth mentioning: preparing this analysis we found every visitor shared one rate-limit bucket behind Render's proxy. That is fixed and live: limits now key on the real client address from Cloudflare's CF-Connecting-IP, with Express trust proxy deliberately left off so forged X-Forwarded-For headers are ignored. Verified in production from two machines on 9 October 2026.</a:t>
             </a:r>
             <a:endParaRPr lang="en-US" dirty="0"/>
           </a:p>
@@ -1583,7 +1583,7 @@
           <a:p>
             <a:r>
               <a:rPr lang="en-US" dirty="0"/>
-              <a:t>Separate what was verified automatically from what still needs a physical device. Test counts are for production master and for the console branch. Emphasize: these are correctness tests; they are not load tests, and we have not run a formal load test.</a:t>
+              <a:t>Separate what was verified automatically from what still needs a physical device. Test counts are for production master after the 9 October rollout. Emphasize: these are correctness tests; they are not load tests, and we have not run a formal load test.</a:t>
             </a:r>
             <a:endParaRPr lang="en-US" dirty="0"/>
           </a:p>
@@ -1935,7 +1935,7 @@
           <a:p>
             <a:r>
               <a:rPr lang="en-US" dirty="0"/>
-              <a:t>There is no software limit on people waiting. The cost of each queue event grows with the queue length, because the server recomputes everyone's ETA and sends each waiting person an update. The chart shows bytes one staff dashboard receives per serve cycle, measured locally. We also measured, in a real browser, that one Serve next with 200 waiting caused 305 dashboard requests — a refetch pattern we can fix in software. Hence: comfortable up to about 50 waiting on the free server today.</a:t>
+              <a:t>There is no software limit on people waiting. The cost of each queue event grows with the queue length, because the server recomputes everyone's ETA and sends each waiting person an update. The chart shows bytes one staff dashboard receives per serve cycle, measured locally. We found, in a real browser, that one Serve next with 200 waiting caused hundreds of dashboard requests, and that every iPhone visitor re-read their ticket on every event. Both are fixed and live: one Serve next now costs 2 to 4 dashboard requests and zero visitor re-reads at 50, 200 or 500 waiting. Hence: comfortable up to about 300 to 500 waiting per queue on the free server, Android and iPhone alike — an estimate, not a load test.</a:t>
             </a:r>
             <a:endParaRPr lang="en-US" dirty="0"/>
           </a:p>
@@ -2023,7 +2023,7 @@
           <a:p>
             <a:r>
               <a:rPr lang="en-US" dirty="0"/>
-              <a:t>Read top to bottom. Every row distinguishes the application rule from the infrastructure estimate. One Admin, one live queue is a product rule, not a hosting limit. No limit on organizations does not mean infinite organizations. The platform row is the one faculty will ask about: about four thousand visits a month today, about twenty-five thousand after the software fix, from formulas in the capacity document. SHORT ANSWER if asked: Today LiveQueue runs entirely on free tiers. There is no software limit on people per queue, queues per organization, or organizations. In practice the free deployment is comfortable for about one small organization — one or two queues, a few counters, a couple of hundred visits a day — with up to about 50 people waiting per queue. The first limit is not CPU but the free network-egress quotas, which a dashboard refresh pattern currently amplifies; that is a software fix, after which we estimate roughly five small organizations. The first paid step is Neon Launch, roughly 10 to 20 dollars a month, then Render Starter at 7 dollars to remove cold starts. These are engineering estimates, not load-test results.</a:t>
+              <a:t>Read top to bottom. Every row distinguishes the application rule from the infrastructure estimate. One Admin, one live queue is a product rule, not a hosting limit. No limit on organizations does not mean infinite organizations. The platform row is the one faculty will ask about: about twenty-five thousand visits a month on the free tiers, from formulas in the capacity document. SHORT ANSWER if asked: LiveQueue runs entirely on free tiers. There is no software limit on people per queue, queues per organization, or organizations. With the software fixes now live, we estimate the free deployment is comfortable for about five small organizations with similar business hours — about twenty-five thousand visits a month — and about 300 to 500 people waiting per queue. The first likely limit is Neon's free quotas: 5 GB of data transfer and 100 compute-hours a month. The first paid step is Neon Launch, roughly 10 to 20 dollars a month, then Render Starter at 7 dollars to remove cold starts. These are engineering estimates, not load-test results.</a:t>
             </a:r>
             <a:endParaRPr lang="en-US" dirty="0"/>
           </a:p>
@@ -2111,7 +2111,7 @@
           <a:p>
             <a:r>
               <a:rPr lang="en-US" dirty="0"/>
-              <a:t>Number zero is a code finding to verify first: no trust proxy, so rate limits may be shared platform-wide. Number one surprised us: the first limit is not CPU but the free network-egress quotas, because each queue event makes open dashboards refetch once per waiting person. That is a software fix. Then Neon's compute hours — the reminder job queries every minute, so the database stays awake whenever the backend is — then Render Free's small CPU and one-minute cold start, then Resend's 100 emails a day, but only for queues that email every visitor.</a:t>
+              <a:t>Three software bottlenecks we found are fixed and live since 9 October: the dashboard refetch storm, the iPhone portal's per-visitor re-reads, and the shared rate-limit bucket. What remains is infrastructure. Number one is Neon's free quotas: 5 GB of data transfer and 100 compute-hours a month — the reminder job queries every minute, so the database stays awake whenever the backend is. Then Render Free's small CPU and one-minute cold start, then Render's 5 GB outbound for long queues watched by many staff tabs, then Resend's 100 emails a day, but only for queues that email every visitor.</a:t>
             </a:r>
             <a:endParaRPr lang="en-US" dirty="0"/>
           </a:p>
@@ -2199,7 +2199,7 @@
           <a:p>
             <a:r>
               <a:rPr lang="en-US" dirty="0"/>
-              <a:t>Order matters: fix the software first, because it is free and buys roughly five times more headroom. The first paid step is Neon Launch — pay-as-you-go, about 10 to 20 dollars a month for one small always-busy compute, with 500 GB of egress included. Then Render Starter at 7 dollars for an always-on backend with five times the CPU. Resend Pro only if queues email every visitor. Render prices come from the pricing page as reported by third parties because the official page loads dynamically — confirm in the dashboard.</a:t>
+              <a:t>The free software fixes are done and live, and bought roughly five times more headroom. The first paid step is Neon Launch — pay-as-you-go, about 10 to 20 dollars a month for one small always-busy compute, with 500 GB of egress included. Then Render Starter at 7 dollars for an always-on backend with five times the CPU. Resend Pro only if queues email every visitor. Render prices come from the pricing page as reported by third parties because the official page loads dynamically — confirm in the dashboard.</a:t>
             </a:r>
             <a:endParaRPr lang="en-US" dirty="0"/>
           </a:p>
@@ -2375,7 +2375,7 @@
           <a:p>
             <a:r>
               <a:rPr lang="en-US" dirty="0"/>
-              <a:t>Four stages. Stage 0 is today at zero infrastructure cost. Stage 1 is software only — still free — and is the highest-value next step. Stage 2 is the first paid step at roughly 18 to 27 dollars a month. Stage 3 for a growing multi-organization platform. Stage 4 changes the architecture and should only be priced after a load test tells us how big it needs to be. All figures are estimates with pricing checked today.</a:t>
+              <a:t>Stage 0 was the free deployment before the fixes. Stage 1, software only and still free, is done and live since 9 October 2026 — that is where LiveQueue is today. Stage 2 is the first paid step at roughly 18 to 27 dollars a month. Stage 3 for a growing multi-organization platform. Stage 4 changes the architecture and should only be priced after a load test tells us how big it needs to be. All figures are estimates with pricing checked today.</a:t>
             </a:r>
             <a:endParaRPr lang="en-US" dirty="0"/>
           </a:p>
@@ -2727,7 +2727,7 @@
           <a:p>
             <a:r>
               <a:rPr lang="en-US" dirty="0"/>
-              <a:t>Everything on this slide is implemented and in production, except the Floating Counter Console, which is finished and in review. The key idea: one backend owns the queue, and three kinds of client — Android, iPhone browser and the staff dashboard — stay in sync through realtime events.</a:t>
+              <a:t>Everything on this slide is implemented and in production, including the Floating Counter Console, which went live on 9 October 2026. The key idea: one backend owns the queue, and three kinds of client — Android, iPhone browser and the staff dashboard — stay in sync through realtime events.</a:t>
             </a:r>
             <a:endParaRPr lang="en-US" dirty="0"/>
           </a:p>
@@ -2903,7 +2903,7 @@
           <a:p>
             <a:r>
               <a:rPr lang="en-US" dirty="0"/>
-              <a:t>Walk left to right. Three clients. One backend process on Render runs the REST API, the Socket.io server and two schedulers. PostgreSQL on Neon is the single source of truth via Prisma. Static dashboard and portal are served by Cloudflare Pages — note that API traffic goes straight to Render, not through Cloudflare. Notifications fan out to FCM for the Android app, Web Push for iPhone/iPad visitors who added the Safari portal to their Home Screen, and Resend for email. The console is a fourth surface in review.</a:t>
+              <a:t>Walk left to right. Three clients. One backend process on Render runs the REST API, the Socket.io server and two schedulers. PostgreSQL on Neon is the single source of truth via Prisma. Static dashboard and portal are served by Cloudflare Pages — note that API traffic goes straight to Render, not through Cloudflare. Notifications fan out to FCM for the Android app, Web Push for iPhone/iPad visitors who added the Safari portal to their Home Screen, and Resend for email. The Floating Counter Console is a fourth staff surface, live in production: it shares the dashboard's session, data cache and Socket.io connection.</a:t>
             </a:r>
             <a:endParaRPr lang="en-US" dirty="0"/>
           </a:p>
@@ -2991,7 +2991,7 @@
           <a:p>
             <a:r>
               <a:rPr lang="en-US" dirty="0"/>
-              <a:t>Two lanes. Top: every read and write is a REST request that is authenticated, validated, authorized and usually wrapped in a transaction. Bottom: Socket.io only tells clients that something changed; clients then refetch. Events are never treated as the source of truth and are never replayed, so after a reconnect a client rejoins its rooms and refetches everything.</a:t>
+              <a:t>Two lanes. Top: every read and write is a REST request that is authenticated, validated, authorized and usually wrapped in a transaction. Bottom: Socket.io tells clients that something changed. The staff dashboard batches the resulting refetches, so a burst of events costs one reload per view; the Android app and the iPhone/iPad portal apply the event payload directly, which the server builds with the same function as the REST read. Events are never replayed, so after a reconnect every client rejoins its rooms and re-reads the server's state.</a:t>
             </a:r>
             <a:endParaRPr lang="en-US" dirty="0"/>
           </a:p>
@@ -7652,7 +7652,7 @@
                   <a:schemeClr val="tx1"/>
                 </a:solidFill>
               </a:rPr>
-              <a:t>Rate limits on public, join, auth and sensitive routes</a:t>
+              <a:t>Rate limits per real client (CF-Connecting-IP; spoof-resistant)</a:t>
             </a:r>
             <a:endParaRPr lang="en-US" sz="1200" dirty="0"/>
           </a:p>
@@ -7773,7 +7773,7 @@
                   <a:schemeClr val="tx1"/>
                 </a:solidFill>
               </a:rPr>
-              <a:t>No Express "trust proxy" → limits may be shared across clients behind Render (to verify and fix)</a:t>
+              <a:t>People behind one NAT (campus Wi-Fi, carrier) share a limit</a:t>
             </a:r>
             <a:endParaRPr lang="en-US" sz="1200" dirty="0"/>
           </a:p>
@@ -10436,7 +10436,7 @@
                   <a:schemeClr val="accent1"/>
                 </a:solidFill>
               </a:rPr>
-              <a:t>1,216</a:t>
+              <a:t>1,234</a:t>
             </a:r>
             <a:endParaRPr lang="en-US" sz="3000" dirty="0"/>
           </a:p>
@@ -10508,7 +10508,7 @@
                   <a:schemeClr val="accent1"/>
                 </a:solidFill>
               </a:rPr>
-              <a:t>574</a:t>
+              <a:t>640</a:t>
             </a:r>
             <a:endParaRPr lang="en-US" sz="3000" dirty="0"/>
           </a:p>
@@ -10652,7 +10652,7 @@
                   <a:srgbClr val="64748B"/>
                 </a:solidFill>
               </a:rPr>
-              <a:t>All passing on production master; console branch: 1,222 + 614. Typecheck, lint and production builds clean.</a:t>
+              <a:t>All passing on production master (9 Oct 2026). Typecheck, lint and production builds clean.</a:t>
             </a:r>
             <a:endParaRPr lang="en-US" sz="1100" dirty="0"/>
           </a:p>
@@ -10783,6 +10783,24 @@
                 </a:solidFill>
               </a:rPr>
               <a:t>Android v1.0.6 published, Latest; APK independently verified</a:t>
+            </a:r>
+            <a:endParaRPr lang="en-US" sz="1150" dirty="0"/>
+          </a:p>
+          <a:p>
+            <a:pPr marL="177800" indent="-177800">
+              <a:spcAft>
+                <a:spcPts val="500"/>
+              </a:spcAft>
+              <a:buSzPct val="100000"/>
+              <a:buChar char="•"/>
+            </a:pPr>
+            <a:r>
+              <a:rPr lang="en-US" sz="1150" dirty="0">
+                <a:solidFill>
+                  <a:schemeClr val="tx1"/>
+                </a:solidFill>
+              </a:rPr>
+              <a:t>Console + performance fixes live; per-client rate limits verified</a:t>
             </a:r>
             <a:endParaRPr lang="en-US" sz="1150" dirty="0"/>
           </a:p>
@@ -10939,7 +10957,7 @@
                   <a:schemeClr val="tx1"/>
                 </a:solidFill>
               </a:rPr>
-              <a:t>Floating Console — in review, not deployed</a:t>
+              <a:t>Console always-on-top on a real desktop OS — not verified headlessly</a:t>
             </a:r>
             <a:endParaRPr lang="en-US" sz="1150" dirty="0"/>
           </a:p>
@@ -12818,7 +12836,7 @@
                   <a:srgbClr val="64748B"/>
                 </a:solidFill>
               </a:rPr>
-              <a:t>Domain (tdastudbook.au): separate registration/renewal cost — not verified.   Checked on: 2026-10-08</a:t>
+              <a:t>Domain (tdastudbook.au): separate registration/renewal cost — not verified.   Quotas checked on: 2026-10-08 · production state: 2026-10-09</a:t>
             </a:r>
             <a:endParaRPr lang="en-US" sz="950" dirty="0"/>
           </a:p>
@@ -13849,7 +13867,7 @@
         <p:spPr>
           <a:xfrm>
             <a:off x="457200" y="3977640"/>
-            <a:ext cx="4114800" cy="274320"/>
+            <a:ext cx="4114800" cy="411480"/>
           </a:xfrm>
           <a:prstGeom prst="rect">
             <a:avLst/>
@@ -13867,10 +13885,10 @@
             <a:r>
               <a:rPr lang="en-US" sz="1000" dirty="0">
                 <a:solidFill>
-                  <a:srgbClr val="B91C1C"/>
-                </a:solidFill>
-              </a:rPr>
-              <a:t>1 Serve next, 200 waiting → 305 dashboard requests (MEASURED)</a:t>
+                  <a:srgbClr val="15803D"/>
+                </a:solidFill>
+              </a:rPr>
+              <a:t>1 Serve next, 200 waiting: ~400 → 4 dashboard requests · 0 visitor re-reads (MEASURED, local)</a:t>
             </a:r>
             <a:endParaRPr lang="en-US" sz="1000" dirty="0"/>
           </a:p>
@@ -14179,7 +14197,7 @@
                           <a:ea typeface="Calibri" pitchFamily="34" charset="-122"/>
                           <a:cs typeface="Calibri" pitchFamily="34" charset="-120"/>
                         </a:rPr>
-                        <a:t>Comfortable today</a:t>
+                        <a:t>Comfortable</a:t>
                       </a:r>
                       <a:endParaRPr lang="en-US" sz="1050" dirty="0">
                         <a:latin typeface="Calibri" charset="0"/>
@@ -14244,7 +14262,7 @@
                           <a:ea typeface="Calibri" pitchFamily="34" charset="-122"/>
                           <a:cs typeface="Calibri" pitchFamily="34" charset="-120"/>
                         </a:rPr>
-                        <a:t>≤ ~50 (ESTIMATE)</a:t>
+                        <a:t>~300 – 500 on free CPU (ESTIMATE)</a:t>
                       </a:r>
                       <a:endParaRPr lang="en-US" sz="1050" dirty="0">
                         <a:latin typeface="Calibri" charset="0"/>
@@ -14376,7 +14394,7 @@
                           <a:ea typeface="Calibri" pitchFamily="34" charset="-122"/>
                           <a:cs typeface="Calibri" pitchFamily="34" charset="-120"/>
                         </a:rPr>
-                        <a:t>50 – 150 (ESTIMATE)</a:t>
+                        <a:t>&gt; 500, or many open staff tabs (ESTIMATE)</a:t>
                       </a:r>
                       <a:endParaRPr lang="en-US" sz="1050" dirty="0">
                         <a:latin typeface="Calibri" charset="0"/>
@@ -14443,7 +14461,7 @@
                           <a:ea typeface="Calibri" pitchFamily="34" charset="-122"/>
                           <a:cs typeface="Calibri" pitchFamily="34" charset="-120"/>
                         </a:rPr>
-                        <a:t>After refetch fix</a:t>
+                        <a:t>Before the fixes</a:t>
                       </a:r>
                       <a:endParaRPr lang="en-US" sz="1050" dirty="0">
                         <a:latin typeface="Calibri" charset="0"/>
@@ -14508,7 +14526,7 @@
                           <a:ea typeface="Calibri" pitchFamily="34" charset="-122"/>
                           <a:cs typeface="Calibri" pitchFamily="34" charset="-120"/>
                         </a:rPr>
-                        <a:t>~300 – 500 on free CPU (ESTIMATE)</a:t>
+                        <a:t>≤ ~50 (ESTIMATE)</a:t>
                       </a:r>
                       <a:endParaRPr lang="en-US" sz="1050" dirty="0">
                         <a:latin typeface="Calibri" charset="0"/>
@@ -15549,7 +15567,7 @@
                           <a:ea typeface="Calibri" pitchFamily="34" charset="-122"/>
                           <a:cs typeface="Calibri" pitchFamily="34" charset="-120"/>
                         </a:rPr>
-                        <a:t>≤ ~50 waiting · 1–10 counters</a:t>
+                        <a:t>~300–500 waiting · 1–10 counters</a:t>
                       </a:r>
                       <a:endParaRPr lang="en-US" sz="1200" dirty="0">
                         <a:latin typeface="Calibri" charset="0"/>
@@ -15614,7 +15632,7 @@
                           <a:ea typeface="Calibri" pitchFamily="34" charset="-122"/>
                           <a:cs typeface="Calibri" pitchFamily="34" charset="-120"/>
                         </a:rPr>
-                        <a:t>&gt; 150 waiting · &gt; 25 counters</a:t>
+                        <a:t>&gt; 500 waiting · &gt; 25 counters</a:t>
                       </a:r>
                       <a:endParaRPr lang="en-US" sz="1200" dirty="0">
                         <a:latin typeface="Calibri" charset="0"/>
@@ -16073,7 +16091,7 @@
                           <a:ea typeface="Calibri" pitchFamily="34" charset="-122"/>
                           <a:cs typeface="Calibri" pitchFamily="34" charset="-120"/>
                         </a:rPr>
-                        <a:t>≈ 4,000 visits/month today · ≈ 25,000 after refetch fix</a:t>
+                        <a:t>≈ 25,000 visits/month · ~5 small organizations</a:t>
                       </a:r>
                       <a:endParaRPr lang="en-US" sz="1200" dirty="0">
                         <a:latin typeface="Calibri" charset="0"/>
@@ -16138,7 +16156,7 @@
                           <a:ea typeface="Calibri" pitchFamily="34" charset="-122"/>
                           <a:cs typeface="Calibri" pitchFamily="34" charset="-120"/>
                         </a:rPr>
-                        <a:t>Egress or Neon hours exhausted</a:t>
+                        <a:t>Neon free quotas exhausted</a:t>
                       </a:r>
                       <a:endParaRPr lang="en-US" sz="1200" dirty="0">
                         <a:latin typeface="Calibri" charset="0"/>
@@ -16350,11 +16368,11 @@
             <a:avLst/>
           </a:prstGeom>
           <a:solidFill>
-            <a:srgbClr val="B91C1C"/>
+            <a:srgbClr val="15803D"/>
           </a:solidFill>
           <a:ln w="12700">
             <a:solidFill>
-              <a:srgbClr val="B91C1C"/>
+              <a:srgbClr val="15803D"/>
             </a:solidFill>
             <a:prstDash val="solid"/>
           </a:ln>
@@ -16390,7 +16408,7 @@
                   <a:schemeClr val="bg1"/>
                 </a:solidFill>
               </a:rPr>
-              <a:t>0</a:t>
+              <a:t>✓</a:t>
             </a:r>
             <a:endParaRPr lang="en-US" sz="1200" dirty="0"/>
           </a:p>
@@ -16426,7 +16444,7 @@
                   <a:schemeClr val="tx1"/>
                 </a:solidFill>
               </a:rPr>
-              <a:t>Rate limits may be shared by all clients</a:t>
+              <a:t>Fixed and live (9 Oct 2026)</a:t>
             </a:r>
             <a:endParaRPr lang="en-US" sz="1200" dirty="0"/>
           </a:p>
@@ -16440,7 +16458,7 @@
                   <a:srgbClr val="475569"/>
                 </a:solidFill>
               </a:rPr>
-              <a:t>Code finding: no Express "trust proxy" — verify; fix is free</a:t>
+              <a:t>Dashboard refetch storm · iPhone portal re-reads · shared rate-limit bucket</a:t>
             </a:r>
             <a:endParaRPr lang="en-US" sz="1200" dirty="0"/>
           </a:p>
@@ -16537,7 +16555,7 @@
                   <a:schemeClr val="tx1"/>
                 </a:solidFill>
               </a:rPr>
-              <a:t>Network egress: Neon 5 GB + Render 5 GB/month</a:t>
+              <a:t>Neon free quotas: 5 GB transfer + 100 CU-h/month</a:t>
             </a:r>
             <a:endParaRPr lang="en-US" sz="1200" dirty="0"/>
           </a:p>
@@ -16551,7 +16569,7 @@
                   <a:srgbClr val="475569"/>
                 </a:solidFill>
               </a:rPr>
-              <a:t>Amplified by dashboard refetch per waiting person (software fix)</a:t>
+              <a:t>First likely limit; the reminder job keeps the DB awake while the backend is</a:t>
             </a:r>
             <a:endParaRPr lang="en-US" sz="1200" dirty="0"/>
           </a:p>
@@ -16648,7 +16666,7 @@
                   <a:schemeClr val="tx1"/>
                 </a:solidFill>
               </a:rPr>
-              <a:t>Neon compute: 100 CU-h ≈ 400 active hours/month</a:t>
+              <a:t>Render Free: 0.1 CPU, ~1-minute cold start</a:t>
             </a:r>
             <a:endParaRPr lang="en-US" sz="1200" dirty="0"/>
           </a:p>
@@ -16662,7 +16680,7 @@
                   <a:srgbClr val="475569"/>
                 </a:solidFill>
               </a:rPr>
-              <a:t>Reminder job keeps the DB awake while the backend is awake</a:t>
+              <a:t>Per-event ETA work grows with queue length</a:t>
             </a:r>
             <a:endParaRPr lang="en-US" sz="1200" dirty="0"/>
           </a:p>
@@ -16759,7 +16777,7 @@
                   <a:schemeClr val="tx1"/>
                 </a:solidFill>
               </a:rPr>
-              <a:t>Render Free: 0.1 CPU, ~1-minute cold start</a:t>
+              <a:t>Render outbound: 5 GB/month</a:t>
             </a:r>
             <a:endParaRPr lang="en-US" sz="1200" dirty="0"/>
           </a:p>
@@ -16773,7 +16791,7 @@
                   <a:srgbClr val="475569"/>
                 </a:solidFill>
               </a:rPr>
-              <a:t>Per-event work grows with queue length</a:t>
+              <a:t>Socket updates grow with waiting × open staff tabs</a:t>
             </a:r>
             <a:endParaRPr lang="en-US" sz="1200" dirty="0"/>
           </a:p>
@@ -17031,7 +17049,7 @@
                   <a:srgbClr val="64748B"/>
                 </a:solidFill>
               </a:rPr>
-              <a:t>ESTIMATE from measured payloads + published quotas. Checked on: 2026-10-08</a:t>
+              <a:t>ESTIMATE from measured payloads + published quotas. Quotas checked on: 2026-10-08 · production state: 2026-10-09</a:t>
             </a:r>
             <a:endParaRPr lang="en-US" sz="900" dirty="0"/>
           </a:p>
@@ -17534,7 +17552,7 @@
                           <a:ea typeface="Calibri" pitchFamily="34" charset="-122"/>
                           <a:cs typeface="Calibri" pitchFamily="34" charset="-120"/>
                         </a:rPr>
-                        <a:t>Refetch storm / 429s</a:t>
+                        <a:t>Refetch storm / shared limits</a:t>
                       </a:r>
                       <a:endParaRPr lang="en-US" sz="1100" dirty="0">
                         <a:latin typeface="Calibri" charset="0"/>
@@ -17664,7 +17682,7 @@
                           <a:ea typeface="Calibri" pitchFamily="34" charset="-122"/>
                           <a:cs typeface="Calibri" pitchFamily="34" charset="-120"/>
                         </a:rPr>
-                        <a:t>Debounce events; set trust proxy</a:t>
+                        <a:t>Done — live 9 Oct 2026</a:t>
                       </a:r>
                       <a:endParaRPr lang="en-US" sz="1100" dirty="0">
                         <a:latin typeface="Calibri" charset="0"/>
@@ -17729,7 +17747,7 @@
                           <a:ea typeface="Calibri" pitchFamily="34" charset="-122"/>
                           <a:cs typeface="Calibri" pitchFamily="34" charset="-120"/>
                         </a:rPr>
-                        <a:t>Removes O(N) refetches</a:t>
+                        <a:t>Batched refetch · per-client limits</a:t>
                       </a:r>
                       <a:endParaRPr lang="en-US" sz="1100" dirty="0">
                         <a:latin typeface="Calibri" charset="0"/>
@@ -19839,7 +19857,7 @@
                   <a:srgbClr val="64748B"/>
                 </a:solidFill>
               </a:rPr>
-              <a:t>* 0.25 CU × 400–730 h × $0.106/CU-h.  † Render pricing page is dynamic; figures corroborated by third-party listings — confirm in dashboard.  Checked on: 2026-10-08</a:t>
+              <a:t>* 0.25 CU × 400–730 h × $0.106/CU-h.  † Render pricing page is dynamic; figures corroborated by third-party listings — confirm in dashboard.  Quotas checked on: 2026-10-08 · production state: 2026-10-09</a:t>
             </a:r>
             <a:endParaRPr lang="en-US" sz="900" dirty="0"/>
           </a:p>
@@ -20995,7 +21013,7 @@
                   <a:schemeClr val="tx2"/>
                 </a:solidFill>
               </a:rPr>
-              <a:t>Today</a:t>
+              <a:t>Before fixes</a:t>
             </a:r>
             <a:endParaRPr lang="en-US" sz="1300" dirty="0"/>
           </a:p>
@@ -21202,7 +21220,7 @@
                   <a:schemeClr val="tx2"/>
                 </a:solidFill>
               </a:rPr>
-              <a:t>Software first</a:t>
+              <a:t>Today: software fixes live</a:t>
             </a:r>
             <a:endParaRPr lang="en-US" sz="1300" dirty="0"/>
           </a:p>
@@ -21274,7 +21292,7 @@
                   <a:srgbClr val="475569"/>
                 </a:solidFill>
               </a:rPr>
-              <a:t>Refetch fix · trust proxy</a:t>
+              <a:t>Batched refetch · portal payloads · per-client limits</a:t>
             </a:r>
             <a:endParaRPr lang="en-US" sz="1050" dirty="0"/>
           </a:p>
@@ -21967,7 +21985,7 @@
                   <a:srgbClr val="64748B"/>
                 </a:solidFill>
               </a:rPr>
-              <a:t>ESTIMATES, not load-test validated. Fixed vs usage-based: Render plans fixed; Neon Launch usage-based. Domain cost separate. Checked on: 2026-10-08</a:t>
+              <a:t>ESTIMATES, not load-test validated. Fixed vs usage-based: Render plans fixed; Neon Launch usage-based. Domain cost separate. Quotas checked on: 2026-10-08 · production state: 2026-10-09</a:t>
             </a:r>
             <a:endParaRPr lang="en-US" sz="950" dirty="0"/>
           </a:p>
@@ -22187,7 +22205,7 @@
                   <a:schemeClr val="tx1"/>
                 </a:solidFill>
               </a:rPr>
-              <a:t>Per-person event fan-out and dashboard refetch storm</a:t>
+              <a:t>Per-person socket fan-out (grows with waiting × staff tabs)</a:t>
             </a:r>
             <a:endParaRPr lang="en-US" sz="1400" dirty="0"/>
           </a:p>
@@ -22205,7 +22223,7 @@
                   <a:schemeClr val="tx1"/>
                 </a:solidFill>
               </a:rPr>
-              <a:t>In-memory rate limits; trust proxy not set</a:t>
+              <a:t>In-memory rate limits; a shared NAT shares one limit</a:t>
             </a:r>
             <a:endParaRPr lang="en-US" sz="1400" dirty="0"/>
           </a:p>
@@ -24722,7 +24740,7 @@
                   <a:srgbClr val="475569"/>
                 </a:solidFill>
               </a:rPr>
-              <a:t>Always-visible controls (in review)</a:t>
+              <a:t>Always-visible serving controls (live)</a:t>
             </a:r>
             <a:endParaRPr lang="en-US" sz="1100" dirty="0"/>
           </a:p>
@@ -26301,7 +26319,7 @@
                   <a:srgbClr val="475569"/>
                 </a:solidFill>
               </a:rPr>
-              <a:t>Document PiP · in review</a:t>
+              <a:t>Document PiP · fallback dock</a:t>
             </a:r>
             <a:endParaRPr lang="en-US" sz="1200" dirty="0"/>
           </a:p>
@@ -28311,7 +28329,7 @@
                   <a:schemeClr val="tx1"/>
                 </a:solidFill>
               </a:rPr>
-              <a:t>client invalidates</a:t>
+              <a:t>dashboard: batched invalidate</a:t>
             </a:r>
             <a:endParaRPr lang="en-US" sz="1050" dirty="0"/>
           </a:p>
@@ -28325,7 +28343,7 @@
                   <a:schemeClr val="tx1"/>
                 </a:solidFill>
               </a:rPr>
-              <a:t>its cached data</a:t>
+              <a:t>visitors: apply payload</a:t>
             </a:r>
             <a:endParaRPr lang="en-US" sz="1050" dirty="0"/>
           </a:p>
@@ -28412,7 +28430,7 @@
                   <a:schemeClr val="tx1"/>
                 </a:solidFill>
               </a:rPr>
-              <a:t>client refetches</a:t>
+              <a:t>dashboard refetches once</a:t>
             </a:r>
             <a:endParaRPr lang="en-US" sz="1050" dirty="0"/>
           </a:p>
@@ -28426,7 +28444,7 @@
                   <a:schemeClr val="tx1"/>
                 </a:solidFill>
               </a:rPr>
-              <a:t>over REST</a:t>
+              <a:t>per burst over REST</a:t>
             </a:r>
             <a:endParaRPr lang="en-US" sz="1050" dirty="0"/>
           </a:p>
@@ -31655,7 +31673,7 @@
                   <a:srgbClr val="475569"/>
                 </a:solidFill>
               </a:rPr>
-              <a:t>Every device refetches the same truth</a:t>
+              <a:t>Every device converges on the same truth</a:t>
             </a:r>
             <a:endParaRPr lang="en-US" sz="1150" dirty="0"/>
           </a:p>

</xml_diff>

<commit_message>
docs(presentation): console slide badge reads live in production
Co-Authored-By: Claude Opus 5.5 <noreply@anthropic.com>
Claude-Session: https://claude.ai/code/session_012AXSZrFXc46dERhV4B9Z4S
</commit_message>
<xml_diff>
--- a/docs/presentation/LiveQueue_Production_Presentation.pptx
+++ b/docs/presentation/LiveQueue_Production_Presentation.pptx
@@ -134,7 +134,7 @@
   <p:extLst>
     <p:ext uri="{521415D9-36F7-43E2-AB2F-B90AF26B5E84}">
       <p14:sectionLst xmlns:p14="http://schemas.microsoft.com/office/powerpoint/2010/main">
-        <p14:section name="Introduction" id="{14d8c2bc-3198-9f68-289f-6b63c3deef27}">
+        <p14:section name="Introduction" id="{e66fa6dd-7834-b6a5-22b0-c33cc5ca9879}">
           <p14:sldIdLst>
             <p14:sldId id="256"/>
             <p14:sldId id="257"/>
@@ -142,45 +142,45 @@
             <p14:sldId id="259"/>
           </p14:sldIdLst>
         </p14:section>
-        <p14:section name="Architecture" id="{d15e1bf2-6905-9976-f4d8-90d7dcc67188}">
+        <p14:section name="Architecture" id="{b208853f-61cc-ca3b-e4f9-ee3601c669f2}">
           <p14:sldIdLst>
             <p14:sldId id="260"/>
             <p14:sldId id="261"/>
             <p14:sldId id="270"/>
           </p14:sldIdLst>
         </p14:section>
-        <p14:section name="Queue engine" id="{f832b7ad-a739-f5b9-d9db-d793879fcc13}">
+        <p14:section name="Queue engine" id="{754ee1b0-91b3-7e01-e830-496046aed21a}">
           <p14:sldIdLst>
             <p14:sldId id="262"/>
             <p14:sldId id="263"/>
             <p14:sldId id="264"/>
           </p14:sldIdLst>
         </p14:section>
-        <p14:section name="Product" id="{0494b43a-bcc9-b5ea-cca3-bafae06a8418}">
+        <p14:section name="Product" id="{95b61a74-e36a-b1ce-4033-559ea3c238fa}">
           <p14:sldIdLst>
             <p14:sldId id="265"/>
             <p14:sldId id="266"/>
             <p14:sldId id="267"/>
           </p14:sldIdLst>
         </p14:section>
-        <p14:section name="Trust" id="{e3957cbe-b583-c2ce-990d-a40eab71f9cd}">
+        <p14:section name="Trust" id="{2e2377de-90bd-e0a8-355a-25c0edcb362e}">
           <p14:sldIdLst>
             <p14:sldId id="268"/>
             <p14:sldId id="269"/>
           </p14:sldIdLst>
         </p14:section>
-        <p14:section name="Delivery" id="{6c373a7c-2e38-2607-6e2e-d302581390f3}">
+        <p14:section name="Delivery" id="{4d839817-907c-fda3-122b-0bfb6e36b4e7}">
           <p14:sldIdLst>
             <p14:sldId id="271"/>
             <p14:sldId id="272"/>
           </p14:sldIdLst>
         </p14:section>
-        <p14:section name="Capacity, cost and scaling" id="{e0a89dc2-51b6-3d79-f3ba-4f16b0ff872e}">
+        <p14:section name="Capacity, cost and scaling" id="{40b5312e-bbdf-4cde-3f0c-885b33999c9b}">
           <p14:sldIdLst>
             <p14:sldId id="273"/>
           </p14:sldIdLst>
         </p14:section>
-        <p14:section name="Capacity" id="{98f543c0-5299-cf5f-a23d-3bf375cd7577}">
+        <p14:section name="Capacity" id="{f8ee5d63-6540-5fd7-17c5-8c3c20979c74}">
           <p14:sldIdLst>
             <p14:sldId id="274"/>
             <p14:sldId id="275"/>
@@ -189,19 +189,19 @@
             <p14:sldId id="278"/>
           </p14:sldIdLst>
         </p14:section>
-        <p14:section name="Scaling" id="{279e3158-b589-93f3-61df-e77ded5be4a0}">
+        <p14:section name="Scaling" id="{5f2c1b35-851d-c9ad-2b1d-e1f16b02574d}">
           <p14:sldIdLst>
             <p14:sldId id="279"/>
             <p14:sldId id="280"/>
             <p14:sldId id="281"/>
           </p14:sldIdLst>
         </p14:section>
-        <p14:section name="Demo" id="{04698e45-6ab8-3672-69ba-24ac923c5a8b}">
+        <p14:section name="Demo" id="{55d123dc-ebb9-b570-6ab0-829a076688e3}">
           <p14:sldIdLst>
             <p14:sldId id="282"/>
           </p14:sldIdLst>
         </p14:section>
-        <p14:section name="Conclusion" id="{f7ee7eb0-dcb9-acc9-e781-8ba0705fd3cd}">
+        <p14:section name="Conclusion" id="{9574ee59-1195-409e-ca6f-a9e48604f73c}">
           <p14:sldIdLst>
             <p14:sldId id="283"/>
           </p14:sldIdLst>
@@ -967,7 +967,7 @@
           <a:p>
             <a:r>
               <a:rPr lang="en-US" dirty="0"/>
-              <a:t>Newest feature — implemented, tested and ready for review on its own branch, not yet deployed. It uses the browser's Document Picture-in-Picture API to keep a tiny console on top of other windows. It is a React portal from the dashboard's own app, so it shares the same session, cache and single Socket.io connection — there is no second dispatcher. Every button calls the same endpoints as the main page. Browsers without the API get an in-page dock that says honestly it cannot stay on top.</a:t>
+              <a:t>Newest feature — live in production since 9 October 2026. It uses the browser's Document Picture-in-Picture API to keep a tiny console on top of other windows. It is a React portal from the dashboard's own app, so it shares the same session, cache and single Socket.io connection — there is no second dispatcher. Every button calls the same endpoints as the main page, and its refreshes go through the same batching as the dashboard, so it adds no per-event refetches. Browsers without the API get an in-page dock that says honestly it cannot stay on top. Its operating-system-level always-on-top behaviour has not been verified on a real desktop.</a:t>
             </a:r>
             <a:endParaRPr lang="en-US" dirty="0"/>
           </a:p>
@@ -4651,11 +4651,11 @@
             </a:avLst>
           </a:prstGeom>
           <a:solidFill>
-            <a:srgbClr val="FEF3C7"/>
+            <a:srgbClr val="DCFCE7"/>
           </a:solidFill>
           <a:ln w="12700">
             <a:solidFill>
-              <a:srgbClr val="FEF3C7"/>
+              <a:srgbClr val="DCFCE7"/>
             </a:solidFill>
             <a:prstDash val="solid"/>
           </a:ln>
@@ -4688,10 +4688,10 @@
             <a:r>
               <a:rPr lang="en-US" sz="900" b="1" dirty="0">
                 <a:solidFill>
-                  <a:srgbClr val="B45309"/>
-                </a:solidFill>
-              </a:rPr>
-              <a:t>Ready for review · not deployed</a:t>
+                  <a:srgbClr val="15803D"/>
+                </a:solidFill>
+              </a:rPr>
+              <a:t>Live in production · 9 Oct 2026</a:t>
             </a:r>
             <a:endParaRPr lang="en-US" sz="900" dirty="0"/>
           </a:p>

</xml_diff>